<commit_message>
Agregar presentación ejecutiva con maquetas reales de la plataforma
- Presentación de 17 diapositivas con capturas reales de todas las pantallas
- Incluye comparativa KronOS vs RUNAHR y análisis de costos AWS
- Formato PPTX + PDF exportado

Co-Authored-By: Claude Sonnet 4.6 <noreply@anthropic.com>
</commit_message>
<xml_diff>
--- a/docs/KronOS_Maquetas_Ejecutiva_2026.pptx
+++ b/docs/KronOS_Maquetas_Ejecutiva_2026.pptx
@@ -2759,23 +2759,25 @@
         <p:spPr>
           <a:xfrm>
             <a:off x="5852160" y="877824"/>
-            <a:ext cx="2971800" cy="594360"/>
-          </a:xfrm>
-          <a:prstGeom prst="rect">
-            <a:avLst/>
-          </a:prstGeom>
-          <a:noFill/>
-          <a:ln/>
-        </p:spPr>
-        <p:txBody>
-          <a:bodyPr wrap="square" rtlCol="0" anchor="t"/>
+            <a:ext cx="2971800" cy="658368"/>
+          </a:xfrm>
+          <a:prstGeom prst="rect">
+            <a:avLst/>
+          </a:prstGeom>
+          <a:noFill/>
+          <a:ln/>
+        </p:spPr>
+        <p:txBody>
+          <a:bodyPr wrap="square" rtlCol="0" anchor="t">
+            <a:spAutoFit/>
+          </a:bodyPr>
           <a:lstStyle/>
           <a:p>
             <a:pPr indent="0" marL="0">
               <a:buNone/>
             </a:pPr>
             <a:r>
-              <a:rPr lang="en-US" sz="2100" b="1" dirty="0">
+              <a:rPr lang="en-US" sz="2000" b="1" dirty="0">
                 <a:solidFill>
                   <a:srgbClr val="F8FAFC"/>
                 </a:solidFill>
@@ -2785,7 +2787,7 @@
               </a:rPr>
               <a:t>Gestión de Horarios</a:t>
             </a:r>
-            <a:endParaRPr lang="en-US" sz="2100" dirty="0"/>
+            <a:endParaRPr lang="en-US" sz="2000" dirty="0"/>
           </a:p>
         </p:txBody>
       </p:sp>
@@ -2797,7 +2799,7 @@
         </p:nvSpPr>
         <p:spPr>
           <a:xfrm>
-            <a:off x="5852160" y="1536192"/>
+            <a:off x="5852160" y="1591056"/>
             <a:ext cx="2971800" cy="0"/>
           </a:xfrm>
           <a:prstGeom prst="line">
@@ -2820,8 +2822,8 @@
         </p:nvSpPr>
         <p:spPr>
           <a:xfrm>
-            <a:off x="5852160" y="1645920"/>
-            <a:ext cx="2971800" cy="594360"/>
+            <a:off x="5852160" y="1700784"/>
+            <a:ext cx="2971800" cy="566928"/>
           </a:xfrm>
           <a:prstGeom prst="rect">
             <a:avLst/>
@@ -2837,7 +2839,7 @@
               <a:buNone/>
             </a:pPr>
             <a:r>
-              <a:rPr lang="en-US" sz="1250" dirty="0">
+              <a:rPr lang="en-US" sz="1200" dirty="0">
                 <a:solidFill>
                   <a:srgbClr val="94A3B8"/>
                 </a:solidFill>
@@ -2847,7 +2849,7 @@
               </a:rPr>
               <a:t>• Configuración de horarios personalizados por puesto o empleado</a:t>
             </a:r>
-            <a:endParaRPr lang="en-US" sz="1250" dirty="0"/>
+            <a:endParaRPr lang="en-US" sz="1200" dirty="0"/>
           </a:p>
         </p:txBody>
       </p:sp>
@@ -2859,8 +2861,8 @@
         </p:nvSpPr>
         <p:spPr>
           <a:xfrm>
-            <a:off x="5852160" y="2304288"/>
-            <a:ext cx="2971800" cy="594360"/>
+            <a:off x="5852160" y="2322576"/>
+            <a:ext cx="2971800" cy="566928"/>
           </a:xfrm>
           <a:prstGeom prst="rect">
             <a:avLst/>
@@ -2876,7 +2878,7 @@
               <a:buNone/>
             </a:pPr>
             <a:r>
-              <a:rPr lang="en-US" sz="1250" dirty="0">
+              <a:rPr lang="en-US" sz="1200" dirty="0">
                 <a:solidFill>
                   <a:srgbClr val="F8FAFC"/>
                 </a:solidFill>
@@ -2886,7 +2888,7 @@
               </a:rPr>
               <a:t>• Definición de tolerancias de entrada/salida en minutos</a:t>
             </a:r>
-            <a:endParaRPr lang="en-US" sz="1250" dirty="0"/>
+            <a:endParaRPr lang="en-US" sz="1200" dirty="0"/>
           </a:p>
         </p:txBody>
       </p:sp>
@@ -2898,8 +2900,8 @@
         </p:nvSpPr>
         <p:spPr>
           <a:xfrm>
-            <a:off x="5852160" y="2962656"/>
-            <a:ext cx="2971800" cy="594360"/>
+            <a:off x="5852160" y="2944368"/>
+            <a:ext cx="2971800" cy="566928"/>
           </a:xfrm>
           <a:prstGeom prst="rect">
             <a:avLst/>
@@ -2915,7 +2917,7 @@
               <a:buNone/>
             </a:pPr>
             <a:r>
-              <a:rPr lang="en-US" sz="1250" dirty="0">
+              <a:rPr lang="en-US" sz="1200" dirty="0">
                 <a:solidFill>
                   <a:srgbClr val="94A3B8"/>
                 </a:solidFill>
@@ -2925,7 +2927,7 @@
               </a:rPr>
               <a:t>• Horarios especiales con días de descanso configurables</a:t>
             </a:r>
-            <a:endParaRPr lang="en-US" sz="1250" dirty="0"/>
+            <a:endParaRPr lang="en-US" sz="1200" dirty="0"/>
           </a:p>
         </p:txBody>
       </p:sp>
@@ -2937,8 +2939,8 @@
         </p:nvSpPr>
         <p:spPr>
           <a:xfrm>
-            <a:off x="5852160" y="3621024"/>
-            <a:ext cx="2971800" cy="594360"/>
+            <a:off x="5852160" y="3566160"/>
+            <a:ext cx="2971800" cy="566928"/>
           </a:xfrm>
           <a:prstGeom prst="rect">
             <a:avLst/>
@@ -2954,7 +2956,7 @@
               <a:buNone/>
             </a:pPr>
             <a:r>
-              <a:rPr lang="en-US" sz="1250" dirty="0">
+              <a:rPr lang="en-US" sz="1200" dirty="0">
                 <a:solidFill>
                   <a:srgbClr val="F8FAFC"/>
                 </a:solidFill>
@@ -2964,7 +2966,7 @@
               </a:rPr>
               <a:t>• Asignación masiva a grupos de empleados</a:t>
             </a:r>
-            <a:endParaRPr lang="en-US" sz="1250" dirty="0"/>
+            <a:endParaRPr lang="en-US" sz="1200" dirty="0"/>
           </a:p>
         </p:txBody>
       </p:sp>
@@ -3131,23 +3133,25 @@
         <p:spPr>
           <a:xfrm>
             <a:off x="5852160" y="877824"/>
-            <a:ext cx="2971800" cy="594360"/>
-          </a:xfrm>
-          <a:prstGeom prst="rect">
-            <a:avLst/>
-          </a:prstGeom>
-          <a:noFill/>
-          <a:ln/>
-        </p:spPr>
-        <p:txBody>
-          <a:bodyPr wrap="square" rtlCol="0" anchor="t"/>
+            <a:ext cx="2971800" cy="658368"/>
+          </a:xfrm>
+          <a:prstGeom prst="rect">
+            <a:avLst/>
+          </a:prstGeom>
+          <a:noFill/>
+          <a:ln/>
+        </p:spPr>
+        <p:txBody>
+          <a:bodyPr wrap="square" rtlCol="0" anchor="t">
+            <a:spAutoFit/>
+          </a:bodyPr>
           <a:lstStyle/>
           <a:p>
             <a:pPr indent="0" marL="0">
               <a:buNone/>
             </a:pPr>
             <a:r>
-              <a:rPr lang="en-US" sz="2100" b="1" dirty="0">
+              <a:rPr lang="en-US" sz="2000" b="1" dirty="0">
                 <a:solidFill>
                   <a:srgbClr val="F8FAFC"/>
                 </a:solidFill>
@@ -3157,7 +3161,7 @@
               </a:rPr>
               <a:t>Gestión de Sucursales</a:t>
             </a:r>
-            <a:endParaRPr lang="en-US" sz="2100" dirty="0"/>
+            <a:endParaRPr lang="en-US" sz="2000" dirty="0"/>
           </a:p>
         </p:txBody>
       </p:sp>
@@ -3169,7 +3173,7 @@
         </p:nvSpPr>
         <p:spPr>
           <a:xfrm>
-            <a:off x="5852160" y="1536192"/>
+            <a:off x="5852160" y="1591056"/>
             <a:ext cx="2971800" cy="0"/>
           </a:xfrm>
           <a:prstGeom prst="line">
@@ -3192,8 +3196,8 @@
         </p:nvSpPr>
         <p:spPr>
           <a:xfrm>
-            <a:off x="5852160" y="1645920"/>
-            <a:ext cx="2971800" cy="594360"/>
+            <a:off x="5852160" y="1700784"/>
+            <a:ext cx="2971800" cy="566928"/>
           </a:xfrm>
           <a:prstGeom prst="rect">
             <a:avLst/>
@@ -3209,7 +3213,7 @@
               <a:buNone/>
             </a:pPr>
             <a:r>
-              <a:rPr lang="en-US" sz="1250" dirty="0">
+              <a:rPr lang="en-US" sz="1200" dirty="0">
                 <a:solidFill>
                   <a:srgbClr val="94A3B8"/>
                 </a:solidFill>
@@ -3219,7 +3223,7 @@
               </a:rPr>
               <a:t>• Alta y configuración de sucursales con datos de contacto</a:t>
             </a:r>
-            <a:endParaRPr lang="en-US" sz="1250" dirty="0"/>
+            <a:endParaRPr lang="en-US" sz="1200" dirty="0"/>
           </a:p>
         </p:txBody>
       </p:sp>
@@ -3231,8 +3235,8 @@
         </p:nvSpPr>
         <p:spPr>
           <a:xfrm>
-            <a:off x="5852160" y="2304288"/>
-            <a:ext cx="2971800" cy="594360"/>
+            <a:off x="5852160" y="2322576"/>
+            <a:ext cx="2971800" cy="566928"/>
           </a:xfrm>
           <a:prstGeom prst="rect">
             <a:avLst/>
@@ -3248,7 +3252,7 @@
               <a:buNone/>
             </a:pPr>
             <a:r>
-              <a:rPr lang="en-US" sz="1250" dirty="0">
+              <a:rPr lang="en-US" sz="1200" dirty="0">
                 <a:solidFill>
                   <a:srgbClr val="F8FAFC"/>
                 </a:solidFill>
@@ -3258,7 +3262,7 @@
               </a:rPr>
               <a:t>• Parámetros de GPS para validación de ubicación</a:t>
             </a:r>
-            <a:endParaRPr lang="en-US" sz="1250" dirty="0"/>
+            <a:endParaRPr lang="en-US" sz="1200" dirty="0"/>
           </a:p>
         </p:txBody>
       </p:sp>
@@ -3270,8 +3274,8 @@
         </p:nvSpPr>
         <p:spPr>
           <a:xfrm>
-            <a:off x="5852160" y="2962656"/>
-            <a:ext cx="2971800" cy="594360"/>
+            <a:off x="5852160" y="2944368"/>
+            <a:ext cx="2971800" cy="566928"/>
           </a:xfrm>
           <a:prstGeom prst="rect">
             <a:avLst/>
@@ -3287,7 +3291,7 @@
               <a:buNone/>
             </a:pPr>
             <a:r>
-              <a:rPr lang="en-US" sz="1250" dirty="0">
+              <a:rPr lang="en-US" sz="1200" dirty="0">
                 <a:solidFill>
                   <a:srgbClr val="94A3B8"/>
                 </a:solidFill>
@@ -3297,7 +3301,7 @@
               </a:rPr>
               <a:t>• Asignación de horarios y grupos por sucursal</a:t>
             </a:r>
-            <a:endParaRPr lang="en-US" sz="1250" dirty="0"/>
+            <a:endParaRPr lang="en-US" sz="1200" dirty="0"/>
           </a:p>
         </p:txBody>
       </p:sp>
@@ -3309,8 +3313,8 @@
         </p:nvSpPr>
         <p:spPr>
           <a:xfrm>
-            <a:off x="5852160" y="3621024"/>
-            <a:ext cx="2971800" cy="594360"/>
+            <a:off x="5852160" y="3566160"/>
+            <a:ext cx="2971800" cy="566928"/>
           </a:xfrm>
           <a:prstGeom prst="rect">
             <a:avLst/>
@@ -3326,7 +3330,7 @@
               <a:buNone/>
             </a:pPr>
             <a:r>
-              <a:rPr lang="en-US" sz="1250" dirty="0">
+              <a:rPr lang="en-US" sz="1200" dirty="0">
                 <a:solidFill>
                   <a:srgbClr val="F8FAFC"/>
                 </a:solidFill>
@@ -3336,7 +3340,7 @@
               </a:rPr>
               <a:t>• Control de estado activo/inactivo de cada sede</a:t>
             </a:r>
-            <a:endParaRPr lang="en-US" sz="1250" dirty="0"/>
+            <a:endParaRPr lang="en-US" sz="1200" dirty="0"/>
           </a:p>
         </p:txBody>
       </p:sp>
@@ -3503,23 +3507,25 @@
         <p:spPr>
           <a:xfrm>
             <a:off x="5852160" y="877824"/>
-            <a:ext cx="2971800" cy="594360"/>
-          </a:xfrm>
-          <a:prstGeom prst="rect">
-            <a:avLst/>
-          </a:prstGeom>
-          <a:noFill/>
-          <a:ln/>
-        </p:spPr>
-        <p:txBody>
-          <a:bodyPr wrap="square" rtlCol="0" anchor="t"/>
+            <a:ext cx="2971800" cy="658368"/>
+          </a:xfrm>
+          <a:prstGeom prst="rect">
+            <a:avLst/>
+          </a:prstGeom>
+          <a:noFill/>
+          <a:ln/>
+        </p:spPr>
+        <p:txBody>
+          <a:bodyPr wrap="square" rtlCol="0" anchor="t">
+            <a:spAutoFit/>
+          </a:bodyPr>
           <a:lstStyle/>
           <a:p>
             <a:pPr indent="0" marL="0">
               <a:buNone/>
             </a:pPr>
             <a:r>
-              <a:rPr lang="en-US" sz="2100" b="1" dirty="0">
+              <a:rPr lang="en-US" sz="2000" b="1" dirty="0">
                 <a:solidFill>
                   <a:srgbClr val="F8FAFC"/>
                 </a:solidFill>
@@ -3529,7 +3535,7 @@
               </a:rPr>
               <a:t>Puestos y Áreas</a:t>
             </a:r>
-            <a:endParaRPr lang="en-US" sz="2100" dirty="0"/>
+            <a:endParaRPr lang="en-US" sz="2000" dirty="0"/>
           </a:p>
         </p:txBody>
       </p:sp>
@@ -3541,7 +3547,7 @@
         </p:nvSpPr>
         <p:spPr>
           <a:xfrm>
-            <a:off x="5852160" y="1536192"/>
+            <a:off x="5852160" y="1591056"/>
             <a:ext cx="2971800" cy="0"/>
           </a:xfrm>
           <a:prstGeom prst="line">
@@ -3564,8 +3570,8 @@
         </p:nvSpPr>
         <p:spPr>
           <a:xfrm>
-            <a:off x="5852160" y="1645920"/>
-            <a:ext cx="2971800" cy="594360"/>
+            <a:off x="5852160" y="1700784"/>
+            <a:ext cx="2971800" cy="566928"/>
           </a:xfrm>
           <a:prstGeom prst="rect">
             <a:avLst/>
@@ -3581,7 +3587,7 @@
               <a:buNone/>
             </a:pPr>
             <a:r>
-              <a:rPr lang="en-US" sz="1250" dirty="0">
+              <a:rPr lang="en-US" sz="1200" dirty="0">
                 <a:solidFill>
                   <a:srgbClr val="94A3B8"/>
                 </a:solidFill>
@@ -3591,7 +3597,7 @@
               </a:rPr>
               <a:t>• Catálogo de puestos con horario y área organizacional asignados</a:t>
             </a:r>
-            <a:endParaRPr lang="en-US" sz="1250" dirty="0"/>
+            <a:endParaRPr lang="en-US" sz="1200" dirty="0"/>
           </a:p>
         </p:txBody>
       </p:sp>
@@ -3603,8 +3609,8 @@
         </p:nvSpPr>
         <p:spPr>
           <a:xfrm>
-            <a:off x="5852160" y="2304288"/>
-            <a:ext cx="2971800" cy="594360"/>
+            <a:off x="5852160" y="2322576"/>
+            <a:ext cx="2971800" cy="566928"/>
           </a:xfrm>
           <a:prstGeom prst="rect">
             <a:avLst/>
@@ -3620,7 +3626,7 @@
               <a:buNone/>
             </a:pPr>
             <a:r>
-              <a:rPr lang="en-US" sz="1250" dirty="0">
+              <a:rPr lang="en-US" sz="1200" dirty="0">
                 <a:solidFill>
                   <a:srgbClr val="F8FAFC"/>
                 </a:solidFill>
@@ -3630,7 +3636,7 @@
               </a:rPr>
               <a:t>• Estructura de áreas departamentales configurable</a:t>
             </a:r>
-            <a:endParaRPr lang="en-US" sz="1250" dirty="0"/>
+            <a:endParaRPr lang="en-US" sz="1200" dirty="0"/>
           </a:p>
         </p:txBody>
       </p:sp>
@@ -3642,8 +3648,8 @@
         </p:nvSpPr>
         <p:spPr>
           <a:xfrm>
-            <a:off x="5852160" y="2962656"/>
-            <a:ext cx="2971800" cy="594360"/>
+            <a:off x="5852160" y="2944368"/>
+            <a:ext cx="2971800" cy="566928"/>
           </a:xfrm>
           <a:prstGeom prst="rect">
             <a:avLst/>
@@ -3659,7 +3665,7 @@
               <a:buNone/>
             </a:pPr>
             <a:r>
-              <a:rPr lang="en-US" sz="1250" dirty="0">
+              <a:rPr lang="en-US" sz="1200" dirty="0">
                 <a:solidFill>
                   <a:srgbClr val="94A3B8"/>
                 </a:solidFill>
@@ -3669,7 +3675,7 @@
               </a:rPr>
               <a:t>• Vinculación directa con empleados para reportes precisos</a:t>
             </a:r>
-            <a:endParaRPr lang="en-US" sz="1250" dirty="0"/>
+            <a:endParaRPr lang="en-US" sz="1200" dirty="0"/>
           </a:p>
         </p:txBody>
       </p:sp>
@@ -3681,8 +3687,8 @@
         </p:nvSpPr>
         <p:spPr>
           <a:xfrm>
-            <a:off x="5852160" y="3621024"/>
-            <a:ext cx="2971800" cy="594360"/>
+            <a:off x="5852160" y="3566160"/>
+            <a:ext cx="2971800" cy="566928"/>
           </a:xfrm>
           <a:prstGeom prst="rect">
             <a:avLst/>
@@ -3698,7 +3704,7 @@
               <a:buNone/>
             </a:pPr>
             <a:r>
-              <a:rPr lang="en-US" sz="1250" dirty="0">
+              <a:rPr lang="en-US" sz="1200" dirty="0">
                 <a:solidFill>
                   <a:srgbClr val="F8FAFC"/>
                 </a:solidFill>
@@ -3708,7 +3714,7 @@
               </a:rPr>
               <a:t>• Base para filtrado y segmentación de comunicados</a:t>
             </a:r>
-            <a:endParaRPr lang="en-US" sz="1250" dirty="0"/>
+            <a:endParaRPr lang="en-US" sz="1200" dirty="0"/>
           </a:p>
         </p:txBody>
       </p:sp>
@@ -3875,23 +3881,25 @@
         <p:spPr>
           <a:xfrm>
             <a:off x="5852160" y="877824"/>
-            <a:ext cx="2971800" cy="594360"/>
-          </a:xfrm>
-          <a:prstGeom prst="rect">
-            <a:avLst/>
-          </a:prstGeom>
-          <a:noFill/>
-          <a:ln/>
-        </p:spPr>
-        <p:txBody>
-          <a:bodyPr wrap="square" rtlCol="0" anchor="t"/>
+            <a:ext cx="2971800" cy="658368"/>
+          </a:xfrm>
+          <a:prstGeom prst="rect">
+            <a:avLst/>
+          </a:prstGeom>
+          <a:noFill/>
+          <a:ln/>
+        </p:spPr>
+        <p:txBody>
+          <a:bodyPr wrap="square" rtlCol="0" anchor="t">
+            <a:spAutoFit/>
+          </a:bodyPr>
           <a:lstStyle/>
           <a:p>
             <a:pPr indent="0" marL="0">
               <a:buNone/>
             </a:pPr>
             <a:r>
-              <a:rPr lang="en-US" sz="2100" b="1" dirty="0">
+              <a:rPr lang="en-US" sz="2000" b="1" dirty="0">
                 <a:solidFill>
                   <a:srgbClr val="F8FAFC"/>
                 </a:solidFill>
@@ -3901,7 +3909,7 @@
               </a:rPr>
               <a:t>Configuración de Empresa</a:t>
             </a:r>
-            <a:endParaRPr lang="en-US" sz="2100" dirty="0"/>
+            <a:endParaRPr lang="en-US" sz="2000" dirty="0"/>
           </a:p>
         </p:txBody>
       </p:sp>
@@ -3913,7 +3921,7 @@
         </p:nvSpPr>
         <p:spPr>
           <a:xfrm>
-            <a:off x="5852160" y="1536192"/>
+            <a:off x="5852160" y="1591056"/>
             <a:ext cx="2971800" cy="0"/>
           </a:xfrm>
           <a:prstGeom prst="line">
@@ -3936,8 +3944,8 @@
         </p:nvSpPr>
         <p:spPr>
           <a:xfrm>
-            <a:off x="5852160" y="1645920"/>
-            <a:ext cx="2971800" cy="594360"/>
+            <a:off x="5852160" y="1700784"/>
+            <a:ext cx="2971800" cy="566928"/>
           </a:xfrm>
           <a:prstGeom prst="rect">
             <a:avLst/>
@@ -3953,7 +3961,7 @@
               <a:buNone/>
             </a:pPr>
             <a:r>
-              <a:rPr lang="en-US" sz="1250" dirty="0">
+              <a:rPr lang="en-US" sz="1200" dirty="0">
                 <a:solidFill>
                   <a:srgbClr val="94A3B8"/>
                 </a:solidFill>
@@ -3963,7 +3971,7 @@
               </a:rPr>
               <a:t>• Datos corporativos y de contacto centralizados</a:t>
             </a:r>
-            <a:endParaRPr lang="en-US" sz="1250" dirty="0"/>
+            <a:endParaRPr lang="en-US" sz="1200" dirty="0"/>
           </a:p>
         </p:txBody>
       </p:sp>
@@ -3975,8 +3983,8 @@
         </p:nvSpPr>
         <p:spPr>
           <a:xfrm>
-            <a:off x="5852160" y="2304288"/>
-            <a:ext cx="2971800" cy="594360"/>
+            <a:off x="5852160" y="2322576"/>
+            <a:ext cx="2971800" cy="566928"/>
           </a:xfrm>
           <a:prstGeom prst="rect">
             <a:avLst/>
@@ -3992,7 +4000,7 @@
               <a:buNone/>
             </a:pPr>
             <a:r>
-              <a:rPr lang="en-US" sz="1250" dirty="0">
+              <a:rPr lang="en-US" sz="1200" dirty="0">
                 <a:solidFill>
                   <a:srgbClr val="F8FAFC"/>
                 </a:solidFill>
@@ -4002,7 +4010,7 @@
               </a:rPr>
               <a:t>• Logo e identidad visual de la organización</a:t>
             </a:r>
-            <a:endParaRPr lang="en-US" sz="1250" dirty="0"/>
+            <a:endParaRPr lang="en-US" sz="1200" dirty="0"/>
           </a:p>
         </p:txBody>
       </p:sp>
@@ -4014,8 +4022,8 @@
         </p:nvSpPr>
         <p:spPr>
           <a:xfrm>
-            <a:off x="5852160" y="2962656"/>
-            <a:ext cx="2971800" cy="594360"/>
+            <a:off x="5852160" y="2944368"/>
+            <a:ext cx="2971800" cy="566928"/>
           </a:xfrm>
           <a:prstGeom prst="rect">
             <a:avLst/>
@@ -4031,7 +4039,7 @@
               <a:buNone/>
             </a:pPr>
             <a:r>
-              <a:rPr lang="en-US" sz="1250" dirty="0">
+              <a:rPr lang="en-US" sz="1200" dirty="0">
                 <a:solidFill>
                   <a:srgbClr val="94A3B8"/>
                 </a:solidFill>
@@ -4041,7 +4049,7 @@
               </a:rPr>
               <a:t>• Parámetros globales del sistema</a:t>
             </a:r>
-            <a:endParaRPr lang="en-US" sz="1250" dirty="0"/>
+            <a:endParaRPr lang="en-US" sz="1200" dirty="0"/>
           </a:p>
         </p:txBody>
       </p:sp>
@@ -4053,8 +4061,8 @@
         </p:nvSpPr>
         <p:spPr>
           <a:xfrm>
-            <a:off x="5852160" y="3621024"/>
-            <a:ext cx="2971800" cy="594360"/>
+            <a:off x="5852160" y="3566160"/>
+            <a:ext cx="2971800" cy="566928"/>
           </a:xfrm>
           <a:prstGeom prst="rect">
             <a:avLst/>
@@ -4070,7 +4078,7 @@
               <a:buNone/>
             </a:pPr>
             <a:r>
-              <a:rPr lang="en-US" sz="1250" dirty="0">
+              <a:rPr lang="en-US" sz="1200" dirty="0">
                 <a:solidFill>
                   <a:srgbClr val="F8FAFC"/>
                 </a:solidFill>
@@ -4080,7 +4088,7 @@
               </a:rPr>
               <a:t>• Gestión de múltiples corporativos desde una sola instancia</a:t>
             </a:r>
-            <a:endParaRPr lang="en-US" sz="1250" dirty="0"/>
+            <a:endParaRPr lang="en-US" sz="1200" dirty="0"/>
           </a:p>
         </p:txBody>
       </p:sp>
@@ -4247,23 +4255,25 @@
         <p:spPr>
           <a:xfrm>
             <a:off x="5852160" y="877824"/>
-            <a:ext cx="2971800" cy="594360"/>
-          </a:xfrm>
-          <a:prstGeom prst="rect">
-            <a:avLst/>
-          </a:prstGeom>
-          <a:noFill/>
-          <a:ln/>
-        </p:spPr>
-        <p:txBody>
-          <a:bodyPr wrap="square" rtlCol="0" anchor="t"/>
+            <a:ext cx="2971800" cy="658368"/>
+          </a:xfrm>
+          <a:prstGeom prst="rect">
+            <a:avLst/>
+          </a:prstGeom>
+          <a:noFill/>
+          <a:ln/>
+        </p:spPr>
+        <p:txBody>
+          <a:bodyPr wrap="square" rtlCol="0" anchor="t">
+            <a:spAutoFit/>
+          </a:bodyPr>
           <a:lstStyle/>
           <a:p>
             <a:pPr indent="0" marL="0">
               <a:buNone/>
             </a:pPr>
             <a:r>
-              <a:rPr lang="en-US" sz="2100" b="1" dirty="0">
+              <a:rPr lang="en-US" sz="2000" b="1" dirty="0">
                 <a:solidFill>
                   <a:srgbClr val="F8FAFC"/>
                 </a:solidFill>
@@ -4273,7 +4283,7 @@
               </a:rPr>
               <a:t>Comunicados y Anuncios</a:t>
             </a:r>
-            <a:endParaRPr lang="en-US" sz="2100" dirty="0"/>
+            <a:endParaRPr lang="en-US" sz="2000" dirty="0"/>
           </a:p>
         </p:txBody>
       </p:sp>
@@ -4285,7 +4295,7 @@
         </p:nvSpPr>
         <p:spPr>
           <a:xfrm>
-            <a:off x="5852160" y="1536192"/>
+            <a:off x="5852160" y="1591056"/>
             <a:ext cx="2971800" cy="0"/>
           </a:xfrm>
           <a:prstGeom prst="line">
@@ -4308,8 +4318,8 @@
         </p:nvSpPr>
         <p:spPr>
           <a:xfrm>
-            <a:off x="5852160" y="1645920"/>
-            <a:ext cx="2971800" cy="594360"/>
+            <a:off x="5852160" y="1700784"/>
+            <a:ext cx="2971800" cy="566928"/>
           </a:xfrm>
           <a:prstGeom prst="rect">
             <a:avLst/>
@@ -4325,7 +4335,7 @@
               <a:buNone/>
             </a:pPr>
             <a:r>
-              <a:rPr lang="en-US" sz="1250" dirty="0">
+              <a:rPr lang="en-US" sz="1200" dirty="0">
                 <a:solidFill>
                   <a:srgbClr val="94A3B8"/>
                 </a:solidFill>
@@ -4335,7 +4345,7 @@
               </a:rPr>
               <a:t>• Editor visual con soporte de imágenes y botones de acción</a:t>
             </a:r>
-            <a:endParaRPr lang="en-US" sz="1250" dirty="0"/>
+            <a:endParaRPr lang="en-US" sz="1200" dirty="0"/>
           </a:p>
         </p:txBody>
       </p:sp>
@@ -4347,8 +4357,8 @@
         </p:nvSpPr>
         <p:spPr>
           <a:xfrm>
-            <a:off x="5852160" y="2304288"/>
-            <a:ext cx="2971800" cy="594360"/>
+            <a:off x="5852160" y="2322576"/>
+            <a:ext cx="2971800" cy="566928"/>
           </a:xfrm>
           <a:prstGeom prst="rect">
             <a:avLst/>
@@ -4364,7 +4374,7 @@
               <a:buNone/>
             </a:pPr>
             <a:r>
-              <a:rPr lang="en-US" sz="1250" dirty="0">
+              <a:rPr lang="en-US" sz="1200" dirty="0">
                 <a:solidFill>
                   <a:srgbClr val="F8FAFC"/>
                 </a:solidFill>
@@ -4374,7 +4384,7 @@
               </a:rPr>
               <a:t>• Segmentación por grupos, áreas o personas específicas</a:t>
             </a:r>
-            <a:endParaRPr lang="en-US" sz="1250" dirty="0"/>
+            <a:endParaRPr lang="en-US" sz="1200" dirty="0"/>
           </a:p>
         </p:txBody>
       </p:sp>
@@ -4386,8 +4396,8 @@
         </p:nvSpPr>
         <p:spPr>
           <a:xfrm>
-            <a:off x="5852160" y="2962656"/>
-            <a:ext cx="2971800" cy="594360"/>
+            <a:off x="5852160" y="2944368"/>
+            <a:ext cx="2971800" cy="566928"/>
           </a:xfrm>
           <a:prstGeom prst="rect">
             <a:avLst/>
@@ -4403,7 +4413,7 @@
               <a:buNone/>
             </a:pPr>
             <a:r>
-              <a:rPr lang="en-US" sz="1250" dirty="0">
+              <a:rPr lang="en-US" sz="1200" dirty="0">
                 <a:solidFill>
                   <a:srgbClr val="94A3B8"/>
                 </a:solidFill>
@@ -4413,7 +4423,7 @@
               </a:rPr>
               <a:t>• Programación de publicación y fecha de vencimiento</a:t>
             </a:r>
-            <a:endParaRPr lang="en-US" sz="1250" dirty="0"/>
+            <a:endParaRPr lang="en-US" sz="1200" dirty="0"/>
           </a:p>
         </p:txBody>
       </p:sp>
@@ -4425,8 +4435,8 @@
         </p:nvSpPr>
         <p:spPr>
           <a:xfrm>
-            <a:off x="5852160" y="3621024"/>
-            <a:ext cx="2971800" cy="594360"/>
+            <a:off x="5852160" y="3566160"/>
+            <a:ext cx="2971800" cy="566928"/>
           </a:xfrm>
           <a:prstGeom prst="rect">
             <a:avLst/>
@@ -4442,7 +4452,7 @@
               <a:buNone/>
             </a:pPr>
             <a:r>
-              <a:rPr lang="en-US" sz="1250" dirty="0">
+              <a:rPr lang="en-US" sz="1200" dirty="0">
                 <a:solidFill>
                   <a:srgbClr val="F8FAFC"/>
                 </a:solidFill>
@@ -4452,7 +4462,7 @@
               </a:rPr>
               <a:t>• Panel lateral visible en tiempo real para todos los colaboradores</a:t>
             </a:r>
-            <a:endParaRPr lang="en-US" sz="1250" dirty="0"/>
+            <a:endParaRPr lang="en-US" sz="1200" dirty="0"/>
           </a:p>
         </p:txBody>
       </p:sp>
@@ -8532,11 +8542,13 @@
         </p:nvSpPr>
         <p:spPr>
           <a:xfrm>
-            <a:off x="411480" y="1088136"/>
-            <a:ext cx="274320" cy="274320"/>
-          </a:xfrm>
-          <a:prstGeom prst="ellipse">
-            <a:avLst/>
+            <a:off x="411480" y="1069848"/>
+            <a:ext cx="347472" cy="292608"/>
+          </a:xfrm>
+          <a:prstGeom prst="rect">
+            <a:avLst>
+              <a:gd name="adj" fmla="val 18750"/>
+            </a:avLst>
           </a:prstGeom>
           <a:solidFill>
             <a:srgbClr val="4ADE80"/>
@@ -8557,8 +8569,8 @@
         </p:nvSpPr>
         <p:spPr>
           <a:xfrm>
-            <a:off x="411480" y="1088136"/>
-            <a:ext cx="274320" cy="274320"/>
+            <a:off x="411480" y="1069848"/>
+            <a:ext cx="347472" cy="292608"/>
           </a:xfrm>
           <a:prstGeom prst="rect">
             <a:avLst/>
@@ -8574,7 +8586,7 @@
               <a:buNone/>
             </a:pPr>
             <a:r>
-              <a:rPr lang="en-US" sz="1000" b="1" dirty="0">
+              <a:rPr lang="en-US" sz="1100" b="1" dirty="0">
                 <a:solidFill>
                   <a:srgbClr val="0B0F1A"/>
                 </a:solidFill>
@@ -8584,7 +8596,7 @@
               </a:rPr>
               <a:t>1</a:t>
             </a:r>
-            <a:endParaRPr lang="en-US" sz="1000" dirty="0"/>
+            <a:endParaRPr lang="en-US" sz="1100" dirty="0"/>
           </a:p>
         </p:txBody>
       </p:sp>
@@ -8596,8 +8608,8 @@
         </p:nvSpPr>
         <p:spPr>
           <a:xfrm>
-            <a:off x="777240" y="1051560"/>
-            <a:ext cx="3474720" cy="365760"/>
+            <a:off x="868680" y="1051560"/>
+            <a:ext cx="3383280" cy="365760"/>
           </a:xfrm>
           <a:prstGeom prst="rect">
             <a:avLst/>
@@ -8635,11 +8647,13 @@
         </p:nvSpPr>
         <p:spPr>
           <a:xfrm>
-            <a:off x="411480" y="1655064"/>
-            <a:ext cx="274320" cy="274320"/>
-          </a:xfrm>
-          <a:prstGeom prst="ellipse">
-            <a:avLst/>
+            <a:off x="411480" y="1636776"/>
+            <a:ext cx="347472" cy="292608"/>
+          </a:xfrm>
+          <a:prstGeom prst="rect">
+            <a:avLst>
+              <a:gd name="adj" fmla="val 18750"/>
+            </a:avLst>
           </a:prstGeom>
           <a:solidFill>
             <a:srgbClr val="4ADE80"/>
@@ -8660,8 +8674,8 @@
         </p:nvSpPr>
         <p:spPr>
           <a:xfrm>
-            <a:off x="411480" y="1655064"/>
-            <a:ext cx="274320" cy="274320"/>
+            <a:off x="411480" y="1636776"/>
+            <a:ext cx="347472" cy="292608"/>
           </a:xfrm>
           <a:prstGeom prst="rect">
             <a:avLst/>
@@ -8677,7 +8691,7 @@
               <a:buNone/>
             </a:pPr>
             <a:r>
-              <a:rPr lang="en-US" sz="1000" b="1" dirty="0">
+              <a:rPr lang="en-US" sz="1100" b="1" dirty="0">
                 <a:solidFill>
                   <a:srgbClr val="0B0F1A"/>
                 </a:solidFill>
@@ -8687,7 +8701,7 @@
               </a:rPr>
               <a:t>2</a:t>
             </a:r>
-            <a:endParaRPr lang="en-US" sz="1000" dirty="0"/>
+            <a:endParaRPr lang="en-US" sz="1100" dirty="0"/>
           </a:p>
         </p:txBody>
       </p:sp>
@@ -8699,8 +8713,8 @@
         </p:nvSpPr>
         <p:spPr>
           <a:xfrm>
-            <a:off x="777240" y="1618488"/>
-            <a:ext cx="3474720" cy="365760"/>
+            <a:off x="868680" y="1618488"/>
+            <a:ext cx="3383280" cy="365760"/>
           </a:xfrm>
           <a:prstGeom prst="rect">
             <a:avLst/>
@@ -8738,11 +8752,13 @@
         </p:nvSpPr>
         <p:spPr>
           <a:xfrm>
-            <a:off x="411480" y="2221992"/>
-            <a:ext cx="274320" cy="274320"/>
-          </a:xfrm>
-          <a:prstGeom prst="ellipse">
-            <a:avLst/>
+            <a:off x="411480" y="2203704"/>
+            <a:ext cx="347472" cy="292608"/>
+          </a:xfrm>
+          <a:prstGeom prst="rect">
+            <a:avLst>
+              <a:gd name="adj" fmla="val 18750"/>
+            </a:avLst>
           </a:prstGeom>
           <a:solidFill>
             <a:srgbClr val="4ADE80"/>
@@ -8763,8 +8779,8 @@
         </p:nvSpPr>
         <p:spPr>
           <a:xfrm>
-            <a:off x="411480" y="2221992"/>
-            <a:ext cx="274320" cy="274320"/>
+            <a:off x="411480" y="2203704"/>
+            <a:ext cx="347472" cy="292608"/>
           </a:xfrm>
           <a:prstGeom prst="rect">
             <a:avLst/>
@@ -8780,7 +8796,7 @@
               <a:buNone/>
             </a:pPr>
             <a:r>
-              <a:rPr lang="en-US" sz="1000" b="1" dirty="0">
+              <a:rPr lang="en-US" sz="1100" b="1" dirty="0">
                 <a:solidFill>
                   <a:srgbClr val="0B0F1A"/>
                 </a:solidFill>
@@ -8790,7 +8806,7 @@
               </a:rPr>
               <a:t>3</a:t>
             </a:r>
-            <a:endParaRPr lang="en-US" sz="1000" dirty="0"/>
+            <a:endParaRPr lang="en-US" sz="1100" dirty="0"/>
           </a:p>
         </p:txBody>
       </p:sp>
@@ -8802,8 +8818,8 @@
         </p:nvSpPr>
         <p:spPr>
           <a:xfrm>
-            <a:off x="777240" y="2185416"/>
-            <a:ext cx="3474720" cy="365760"/>
+            <a:off x="868680" y="2185416"/>
+            <a:ext cx="3383280" cy="365760"/>
           </a:xfrm>
           <a:prstGeom prst="rect">
             <a:avLst/>
@@ -8841,11 +8857,13 @@
         </p:nvSpPr>
         <p:spPr>
           <a:xfrm>
-            <a:off x="411480" y="2788920"/>
-            <a:ext cx="274320" cy="274320"/>
-          </a:xfrm>
-          <a:prstGeom prst="ellipse">
-            <a:avLst/>
+            <a:off x="411480" y="2770632"/>
+            <a:ext cx="347472" cy="292608"/>
+          </a:xfrm>
+          <a:prstGeom prst="rect">
+            <a:avLst>
+              <a:gd name="adj" fmla="val 18750"/>
+            </a:avLst>
           </a:prstGeom>
           <a:solidFill>
             <a:srgbClr val="4ADE80"/>
@@ -8866,8 +8884,8 @@
         </p:nvSpPr>
         <p:spPr>
           <a:xfrm>
-            <a:off x="411480" y="2788920"/>
-            <a:ext cx="274320" cy="274320"/>
+            <a:off x="411480" y="2770632"/>
+            <a:ext cx="347472" cy="292608"/>
           </a:xfrm>
           <a:prstGeom prst="rect">
             <a:avLst/>
@@ -8883,7 +8901,7 @@
               <a:buNone/>
             </a:pPr>
             <a:r>
-              <a:rPr lang="en-US" sz="1000" b="1" dirty="0">
+              <a:rPr lang="en-US" sz="1100" b="1" dirty="0">
                 <a:solidFill>
                   <a:srgbClr val="0B0F1A"/>
                 </a:solidFill>
@@ -8893,7 +8911,7 @@
               </a:rPr>
               <a:t>4</a:t>
             </a:r>
-            <a:endParaRPr lang="en-US" sz="1000" dirty="0"/>
+            <a:endParaRPr lang="en-US" sz="1100" dirty="0"/>
           </a:p>
         </p:txBody>
       </p:sp>
@@ -8905,8 +8923,8 @@
         </p:nvSpPr>
         <p:spPr>
           <a:xfrm>
-            <a:off x="777240" y="2752344"/>
-            <a:ext cx="3474720" cy="365760"/>
+            <a:off x="868680" y="2752344"/>
+            <a:ext cx="3383280" cy="365760"/>
           </a:xfrm>
           <a:prstGeom prst="rect">
             <a:avLst/>
@@ -8944,11 +8962,13 @@
         </p:nvSpPr>
         <p:spPr>
           <a:xfrm>
-            <a:off x="411480" y="3355848"/>
-            <a:ext cx="274320" cy="274320"/>
-          </a:xfrm>
-          <a:prstGeom prst="ellipse">
-            <a:avLst/>
+            <a:off x="411480" y="3337560"/>
+            <a:ext cx="347472" cy="292608"/>
+          </a:xfrm>
+          <a:prstGeom prst="rect">
+            <a:avLst>
+              <a:gd name="adj" fmla="val 18750"/>
+            </a:avLst>
           </a:prstGeom>
           <a:solidFill>
             <a:srgbClr val="4ADE80"/>
@@ -8969,8 +8989,8 @@
         </p:nvSpPr>
         <p:spPr>
           <a:xfrm>
-            <a:off x="411480" y="3355848"/>
-            <a:ext cx="274320" cy="274320"/>
+            <a:off x="411480" y="3337560"/>
+            <a:ext cx="347472" cy="292608"/>
           </a:xfrm>
           <a:prstGeom prst="rect">
             <a:avLst/>
@@ -8986,7 +9006,7 @@
               <a:buNone/>
             </a:pPr>
             <a:r>
-              <a:rPr lang="en-US" sz="1000" b="1" dirty="0">
+              <a:rPr lang="en-US" sz="1100" b="1" dirty="0">
                 <a:solidFill>
                   <a:srgbClr val="0B0F1A"/>
                 </a:solidFill>
@@ -8996,7 +9016,7 @@
               </a:rPr>
               <a:t>5</a:t>
             </a:r>
-            <a:endParaRPr lang="en-US" sz="1000" dirty="0"/>
+            <a:endParaRPr lang="en-US" sz="1100" dirty="0"/>
           </a:p>
         </p:txBody>
       </p:sp>
@@ -9008,8 +9028,8 @@
         </p:nvSpPr>
         <p:spPr>
           <a:xfrm>
-            <a:off x="777240" y="3319272"/>
-            <a:ext cx="3474720" cy="365760"/>
+            <a:off x="868680" y="3319272"/>
+            <a:ext cx="3383280" cy="365760"/>
           </a:xfrm>
           <a:prstGeom prst="rect">
             <a:avLst/>
@@ -9047,11 +9067,13 @@
         </p:nvSpPr>
         <p:spPr>
           <a:xfrm>
-            <a:off x="4800600" y="1088136"/>
-            <a:ext cx="274320" cy="274320"/>
-          </a:xfrm>
-          <a:prstGeom prst="ellipse">
-            <a:avLst/>
+            <a:off x="4754880" y="1069848"/>
+            <a:ext cx="347472" cy="292608"/>
+          </a:xfrm>
+          <a:prstGeom prst="rect">
+            <a:avLst>
+              <a:gd name="adj" fmla="val 18750"/>
+            </a:avLst>
           </a:prstGeom>
           <a:solidFill>
             <a:srgbClr val="4ADE80"/>
@@ -9072,8 +9094,8 @@
         </p:nvSpPr>
         <p:spPr>
           <a:xfrm>
-            <a:off x="4800600" y="1088136"/>
-            <a:ext cx="274320" cy="274320"/>
+            <a:off x="4754880" y="1069848"/>
+            <a:ext cx="347472" cy="292608"/>
           </a:xfrm>
           <a:prstGeom prst="rect">
             <a:avLst/>
@@ -9089,7 +9111,7 @@
               <a:buNone/>
             </a:pPr>
             <a:r>
-              <a:rPr lang="en-US" sz="1000" b="1" dirty="0">
+              <a:rPr lang="en-US" sz="1100" b="1" dirty="0">
                 <a:solidFill>
                   <a:srgbClr val="0B0F1A"/>
                 </a:solidFill>
@@ -9099,7 +9121,7 @@
               </a:rPr>
               <a:t>6</a:t>
             </a:r>
-            <a:endParaRPr lang="en-US" sz="1000" dirty="0"/>
+            <a:endParaRPr lang="en-US" sz="1100" dirty="0"/>
           </a:p>
         </p:txBody>
       </p:sp>
@@ -9111,8 +9133,8 @@
         </p:nvSpPr>
         <p:spPr>
           <a:xfrm>
-            <a:off x="5166360" y="1051560"/>
-            <a:ext cx="3474720" cy="365760"/>
+            <a:off x="5212080" y="1051560"/>
+            <a:ext cx="3520440" cy="365760"/>
           </a:xfrm>
           <a:prstGeom prst="rect">
             <a:avLst/>
@@ -9150,11 +9172,13 @@
         </p:nvSpPr>
         <p:spPr>
           <a:xfrm>
-            <a:off x="4800600" y="1655064"/>
-            <a:ext cx="274320" cy="274320"/>
-          </a:xfrm>
-          <a:prstGeom prst="ellipse">
-            <a:avLst/>
+            <a:off x="4754880" y="1636776"/>
+            <a:ext cx="347472" cy="292608"/>
+          </a:xfrm>
+          <a:prstGeom prst="rect">
+            <a:avLst>
+              <a:gd name="adj" fmla="val 18750"/>
+            </a:avLst>
           </a:prstGeom>
           <a:solidFill>
             <a:srgbClr val="4ADE80"/>
@@ -9175,8 +9199,8 @@
         </p:nvSpPr>
         <p:spPr>
           <a:xfrm>
-            <a:off x="4800600" y="1655064"/>
-            <a:ext cx="274320" cy="274320"/>
+            <a:off x="4754880" y="1636776"/>
+            <a:ext cx="347472" cy="292608"/>
           </a:xfrm>
           <a:prstGeom prst="rect">
             <a:avLst/>
@@ -9192,7 +9216,7 @@
               <a:buNone/>
             </a:pPr>
             <a:r>
-              <a:rPr lang="en-US" sz="1000" b="1" dirty="0">
+              <a:rPr lang="en-US" sz="1100" b="1" dirty="0">
                 <a:solidFill>
                   <a:srgbClr val="0B0F1A"/>
                 </a:solidFill>
@@ -9202,7 +9226,7 @@
               </a:rPr>
               <a:t>7</a:t>
             </a:r>
-            <a:endParaRPr lang="en-US" sz="1000" dirty="0"/>
+            <a:endParaRPr lang="en-US" sz="1100" dirty="0"/>
           </a:p>
         </p:txBody>
       </p:sp>
@@ -9214,8 +9238,8 @@
         </p:nvSpPr>
         <p:spPr>
           <a:xfrm>
-            <a:off x="5166360" y="1618488"/>
-            <a:ext cx="3474720" cy="365760"/>
+            <a:off x="5212080" y="1618488"/>
+            <a:ext cx="3520440" cy="365760"/>
           </a:xfrm>
           <a:prstGeom prst="rect">
             <a:avLst/>
@@ -9253,11 +9277,13 @@
         </p:nvSpPr>
         <p:spPr>
           <a:xfrm>
-            <a:off x="4800600" y="2221992"/>
-            <a:ext cx="274320" cy="274320"/>
-          </a:xfrm>
-          <a:prstGeom prst="ellipse">
-            <a:avLst/>
+            <a:off x="4754880" y="2203704"/>
+            <a:ext cx="347472" cy="292608"/>
+          </a:xfrm>
+          <a:prstGeom prst="rect">
+            <a:avLst>
+              <a:gd name="adj" fmla="val 18750"/>
+            </a:avLst>
           </a:prstGeom>
           <a:solidFill>
             <a:srgbClr val="4ADE80"/>
@@ -9278,8 +9304,8 @@
         </p:nvSpPr>
         <p:spPr>
           <a:xfrm>
-            <a:off x="4800600" y="2221992"/>
-            <a:ext cx="274320" cy="274320"/>
+            <a:off x="4754880" y="2203704"/>
+            <a:ext cx="347472" cy="292608"/>
           </a:xfrm>
           <a:prstGeom prst="rect">
             <a:avLst/>
@@ -9295,7 +9321,7 @@
               <a:buNone/>
             </a:pPr>
             <a:r>
-              <a:rPr lang="en-US" sz="1000" b="1" dirty="0">
+              <a:rPr lang="en-US" sz="1100" b="1" dirty="0">
                 <a:solidFill>
                   <a:srgbClr val="0B0F1A"/>
                 </a:solidFill>
@@ -9305,7 +9331,7 @@
               </a:rPr>
               <a:t>8</a:t>
             </a:r>
-            <a:endParaRPr lang="en-US" sz="1000" dirty="0"/>
+            <a:endParaRPr lang="en-US" sz="1100" dirty="0"/>
           </a:p>
         </p:txBody>
       </p:sp>
@@ -9317,8 +9343,8 @@
         </p:nvSpPr>
         <p:spPr>
           <a:xfrm>
-            <a:off x="5166360" y="2185416"/>
-            <a:ext cx="3474720" cy="365760"/>
+            <a:off x="5212080" y="2185416"/>
+            <a:ext cx="3520440" cy="365760"/>
           </a:xfrm>
           <a:prstGeom prst="rect">
             <a:avLst/>
@@ -9356,11 +9382,13 @@
         </p:nvSpPr>
         <p:spPr>
           <a:xfrm>
-            <a:off x="4800600" y="2788920"/>
-            <a:ext cx="274320" cy="274320"/>
-          </a:xfrm>
-          <a:prstGeom prst="ellipse">
-            <a:avLst/>
+            <a:off x="4754880" y="2770632"/>
+            <a:ext cx="347472" cy="292608"/>
+          </a:xfrm>
+          <a:prstGeom prst="rect">
+            <a:avLst>
+              <a:gd name="adj" fmla="val 18750"/>
+            </a:avLst>
           </a:prstGeom>
           <a:solidFill>
             <a:srgbClr val="4ADE80"/>
@@ -9381,8 +9409,8 @@
         </p:nvSpPr>
         <p:spPr>
           <a:xfrm>
-            <a:off x="4800600" y="2788920"/>
-            <a:ext cx="274320" cy="274320"/>
+            <a:off x="4754880" y="2770632"/>
+            <a:ext cx="347472" cy="292608"/>
           </a:xfrm>
           <a:prstGeom prst="rect">
             <a:avLst/>
@@ -9398,7 +9426,7 @@
               <a:buNone/>
             </a:pPr>
             <a:r>
-              <a:rPr lang="en-US" sz="1000" b="1" dirty="0">
+              <a:rPr lang="en-US" sz="1100" b="1" dirty="0">
                 <a:solidFill>
                   <a:srgbClr val="0B0F1A"/>
                 </a:solidFill>
@@ -9408,7 +9436,7 @@
               </a:rPr>
               <a:t>9</a:t>
             </a:r>
-            <a:endParaRPr lang="en-US" sz="1000" dirty="0"/>
+            <a:endParaRPr lang="en-US" sz="1100" dirty="0"/>
           </a:p>
         </p:txBody>
       </p:sp>
@@ -9420,8 +9448,8 @@
         </p:nvSpPr>
         <p:spPr>
           <a:xfrm>
-            <a:off x="5166360" y="2752344"/>
-            <a:ext cx="3474720" cy="365760"/>
+            <a:off x="5212080" y="2752344"/>
+            <a:ext cx="3520440" cy="365760"/>
           </a:xfrm>
           <a:prstGeom prst="rect">
             <a:avLst/>
@@ -9459,11 +9487,13 @@
         </p:nvSpPr>
         <p:spPr>
           <a:xfrm>
-            <a:off x="4800600" y="3355848"/>
-            <a:ext cx="274320" cy="274320"/>
-          </a:xfrm>
-          <a:prstGeom prst="ellipse">
-            <a:avLst/>
+            <a:off x="4754880" y="3337560"/>
+            <a:ext cx="347472" cy="292608"/>
+          </a:xfrm>
+          <a:prstGeom prst="rect">
+            <a:avLst>
+              <a:gd name="adj" fmla="val 18750"/>
+            </a:avLst>
           </a:prstGeom>
           <a:solidFill>
             <a:srgbClr val="4ADE80"/>
@@ -9484,8 +9514,8 @@
         </p:nvSpPr>
         <p:spPr>
           <a:xfrm>
-            <a:off x="4800600" y="3355848"/>
-            <a:ext cx="274320" cy="274320"/>
+            <a:off x="4754880" y="3337560"/>
+            <a:ext cx="347472" cy="292608"/>
           </a:xfrm>
           <a:prstGeom prst="rect">
             <a:avLst/>
@@ -9501,7 +9531,7 @@
               <a:buNone/>
             </a:pPr>
             <a:r>
-              <a:rPr lang="en-US" sz="1000" b="1" dirty="0">
+              <a:rPr lang="en-US" sz="1100" b="1" dirty="0">
                 <a:solidFill>
                   <a:srgbClr val="0B0F1A"/>
                 </a:solidFill>
@@ -9511,7 +9541,7 @@
               </a:rPr>
               <a:t>10</a:t>
             </a:r>
-            <a:endParaRPr lang="en-US" sz="1000" dirty="0"/>
+            <a:endParaRPr lang="en-US" sz="1100" dirty="0"/>
           </a:p>
         </p:txBody>
       </p:sp>
@@ -9523,8 +9553,8 @@
         </p:nvSpPr>
         <p:spPr>
           <a:xfrm>
-            <a:off x="5166360" y="3319272"/>
-            <a:ext cx="3474720" cy="365760"/>
+            <a:off x="5212080" y="3319272"/>
+            <a:ext cx="3520440" cy="365760"/>
           </a:xfrm>
           <a:prstGeom prst="rect">
             <a:avLst/>
@@ -9717,23 +9747,25 @@
         <p:spPr>
           <a:xfrm>
             <a:off x="5852160" y="877824"/>
-            <a:ext cx="2971800" cy="594360"/>
-          </a:xfrm>
-          <a:prstGeom prst="rect">
-            <a:avLst/>
-          </a:prstGeom>
-          <a:noFill/>
-          <a:ln/>
-        </p:spPr>
-        <p:txBody>
-          <a:bodyPr wrap="square" rtlCol="0" anchor="t"/>
+            <a:ext cx="2971800" cy="658368"/>
+          </a:xfrm>
+          <a:prstGeom prst="rect">
+            <a:avLst/>
+          </a:prstGeom>
+          <a:noFill/>
+          <a:ln/>
+        </p:spPr>
+        <p:txBody>
+          <a:bodyPr wrap="square" rtlCol="0" anchor="t">
+            <a:spAutoFit/>
+          </a:bodyPr>
           <a:lstStyle/>
           <a:p>
             <a:pPr indent="0" marL="0">
               <a:buNone/>
             </a:pPr>
             <a:r>
-              <a:rPr lang="en-US" sz="2100" b="1" dirty="0">
+              <a:rPr lang="en-US" sz="2000" b="1" dirty="0">
                 <a:solidFill>
                   <a:srgbClr val="F8FAFC"/>
                 </a:solidFill>
@@ -9743,7 +9775,7 @@
               </a:rPr>
               <a:t>Dashboard Principal</a:t>
             </a:r>
-            <a:endParaRPr lang="en-US" sz="2100" dirty="0"/>
+            <a:endParaRPr lang="en-US" sz="2000" dirty="0"/>
           </a:p>
         </p:txBody>
       </p:sp>
@@ -9755,7 +9787,7 @@
         </p:nvSpPr>
         <p:spPr>
           <a:xfrm>
-            <a:off x="5852160" y="1536192"/>
+            <a:off x="5852160" y="1591056"/>
             <a:ext cx="2971800" cy="0"/>
           </a:xfrm>
           <a:prstGeom prst="line">
@@ -9778,8 +9810,8 @@
         </p:nvSpPr>
         <p:spPr>
           <a:xfrm>
-            <a:off x="5852160" y="1645920"/>
-            <a:ext cx="2971800" cy="594360"/>
+            <a:off x="5852160" y="1700784"/>
+            <a:ext cx="2971800" cy="566928"/>
           </a:xfrm>
           <a:prstGeom prst="rect">
             <a:avLst/>
@@ -9795,7 +9827,7 @@
               <a:buNone/>
             </a:pPr>
             <a:r>
-              <a:rPr lang="en-US" sz="1250" dirty="0">
+              <a:rPr lang="en-US" sz="1200" dirty="0">
                 <a:solidFill>
                   <a:srgbClr val="94A3B8"/>
                 </a:solidFill>
@@ -9805,7 +9837,7 @@
               </a:rPr>
               <a:t>• Vista personalizada de bienvenida por usuario y sucursal</a:t>
             </a:r>
-            <a:endParaRPr lang="en-US" sz="1250" dirty="0"/>
+            <a:endParaRPr lang="en-US" sz="1200" dirty="0"/>
           </a:p>
         </p:txBody>
       </p:sp>
@@ -9817,8 +9849,8 @@
         </p:nvSpPr>
         <p:spPr>
           <a:xfrm>
-            <a:off x="5852160" y="2304288"/>
-            <a:ext cx="2971800" cy="594360"/>
+            <a:off x="5852160" y="2322576"/>
+            <a:ext cx="2971800" cy="566928"/>
           </a:xfrm>
           <a:prstGeom prst="rect">
             <a:avLst/>
@@ -9834,7 +9866,7 @@
               <a:buNone/>
             </a:pPr>
             <a:r>
-              <a:rPr lang="en-US" sz="1250" dirty="0">
+              <a:rPr lang="en-US" sz="1200" dirty="0">
                 <a:solidFill>
                   <a:srgbClr val="F8FAFC"/>
                 </a:solidFill>
@@ -9844,7 +9876,7 @@
               </a:rPr>
               <a:t>• Progreso del día con los 4 pasos de registro (Entrada → Salida final)</a:t>
             </a:r>
-            <a:endParaRPr lang="en-US" sz="1250" dirty="0"/>
+            <a:endParaRPr lang="en-US" sz="1200" dirty="0"/>
           </a:p>
         </p:txBody>
       </p:sp>
@@ -9856,8 +9888,8 @@
         </p:nvSpPr>
         <p:spPr>
           <a:xfrm>
-            <a:off x="5852160" y="2962656"/>
-            <a:ext cx="2971800" cy="594360"/>
+            <a:off x="5852160" y="2944368"/>
+            <a:ext cx="2971800" cy="566928"/>
           </a:xfrm>
           <a:prstGeom prst="rect">
             <a:avLst/>
@@ -9873,7 +9905,7 @@
               <a:buNone/>
             </a:pPr>
             <a:r>
-              <a:rPr lang="en-US" sz="1250" dirty="0">
+              <a:rPr lang="en-US" sz="1200" dirty="0">
                 <a:solidFill>
                   <a:srgbClr val="94A3B8"/>
                 </a:solidFill>
@@ -9883,7 +9915,7 @@
               </a:rPr>
               <a:t>• Panel lateral: Cumpleaños, Personal del día, Anuncios, Links frecuentes</a:t>
             </a:r>
-            <a:endParaRPr lang="en-US" sz="1250" dirty="0"/>
+            <a:endParaRPr lang="en-US" sz="1200" dirty="0"/>
           </a:p>
         </p:txBody>
       </p:sp>
@@ -9895,8 +9927,8 @@
         </p:nvSpPr>
         <p:spPr>
           <a:xfrm>
-            <a:off x="5852160" y="3621024"/>
-            <a:ext cx="2971800" cy="594360"/>
+            <a:off x="5852160" y="3566160"/>
+            <a:ext cx="2971800" cy="566928"/>
           </a:xfrm>
           <a:prstGeom prst="rect">
             <a:avLst/>
@@ -9912,7 +9944,7 @@
               <a:buNone/>
             </a:pPr>
             <a:r>
-              <a:rPr lang="en-US" sz="1250" dirty="0">
+              <a:rPr lang="en-US" sz="1200" dirty="0">
                 <a:solidFill>
                   <a:srgbClr val="F8FAFC"/>
                 </a:solidFill>
@@ -9922,7 +9954,7 @@
               </a:rPr>
               <a:t>• Notificaciones en tiempo real sobre registros pendientes</a:t>
             </a:r>
-            <a:endParaRPr lang="en-US" sz="1250" dirty="0"/>
+            <a:endParaRPr lang="en-US" sz="1200" dirty="0"/>
           </a:p>
         </p:txBody>
       </p:sp>
@@ -10089,23 +10121,25 @@
         <p:spPr>
           <a:xfrm>
             <a:off x="5852160" y="877824"/>
-            <a:ext cx="2971800" cy="594360"/>
-          </a:xfrm>
-          <a:prstGeom prst="rect">
-            <a:avLst/>
-          </a:prstGeom>
-          <a:noFill/>
-          <a:ln/>
-        </p:spPr>
-        <p:txBody>
-          <a:bodyPr wrap="square" rtlCol="0" anchor="t"/>
+            <a:ext cx="2971800" cy="658368"/>
+          </a:xfrm>
+          <a:prstGeom prst="rect">
+            <a:avLst/>
+          </a:prstGeom>
+          <a:noFill/>
+          <a:ln/>
+        </p:spPr>
+        <p:txBody>
+          <a:bodyPr wrap="square" rtlCol="0" anchor="t">
+            <a:spAutoFit/>
+          </a:bodyPr>
           <a:lstStyle/>
           <a:p>
             <a:pPr indent="0" marL="0">
               <a:buNone/>
             </a:pPr>
             <a:r>
-              <a:rPr lang="en-US" sz="2100" b="1" dirty="0">
+              <a:rPr lang="en-US" sz="2000" b="1" dirty="0">
                 <a:solidFill>
                   <a:srgbClr val="F8FAFC"/>
                 </a:solidFill>
@@ -10115,7 +10149,7 @@
               </a:rPr>
               <a:t>Registros de Asistencia</a:t>
             </a:r>
-            <a:endParaRPr lang="en-US" sz="2100" dirty="0"/>
+            <a:endParaRPr lang="en-US" sz="2000" dirty="0"/>
           </a:p>
         </p:txBody>
       </p:sp>
@@ -10127,7 +10161,7 @@
         </p:nvSpPr>
         <p:spPr>
           <a:xfrm>
-            <a:off x="5852160" y="1536192"/>
+            <a:off x="5852160" y="1591056"/>
             <a:ext cx="2971800" cy="0"/>
           </a:xfrm>
           <a:prstGeom prst="line">
@@ -10150,8 +10184,8 @@
         </p:nvSpPr>
         <p:spPr>
           <a:xfrm>
-            <a:off x="5852160" y="1645920"/>
-            <a:ext cx="2971800" cy="594360"/>
+            <a:off x="5852160" y="1700784"/>
+            <a:ext cx="2971800" cy="566928"/>
           </a:xfrm>
           <a:prstGeom prst="rect">
             <a:avLst/>
@@ -10167,7 +10201,7 @@
               <a:buNone/>
             </a:pPr>
             <a:r>
-              <a:rPr lang="en-US" sz="1250" dirty="0">
+              <a:rPr lang="en-US" sz="1200" dirty="0">
                 <a:solidFill>
                   <a:srgbClr val="94A3B8"/>
                 </a:solidFill>
@@ -10177,7 +10211,7 @@
               </a:rPr>
               <a:t>• Historial completo de entradas y salidas por sucursal</a:t>
             </a:r>
-            <a:endParaRPr lang="en-US" sz="1250" dirty="0"/>
+            <a:endParaRPr lang="en-US" sz="1200" dirty="0"/>
           </a:p>
         </p:txBody>
       </p:sp>
@@ -10189,8 +10223,8 @@
         </p:nvSpPr>
         <p:spPr>
           <a:xfrm>
-            <a:off x="5852160" y="2304288"/>
-            <a:ext cx="2971800" cy="594360"/>
+            <a:off x="5852160" y="2322576"/>
+            <a:ext cx="2971800" cy="566928"/>
           </a:xfrm>
           <a:prstGeom prst="rect">
             <a:avLst/>
@@ -10206,7 +10240,7 @@
               <a:buNone/>
             </a:pPr>
             <a:r>
-              <a:rPr lang="en-US" sz="1250" dirty="0">
+              <a:rPr lang="en-US" sz="1200" dirty="0">
                 <a:solidFill>
                   <a:srgbClr val="F8FAFC"/>
                 </a:solidFill>
@@ -10216,7 +10250,7 @@
               </a:rPr>
               <a:t>• Reporte del día con filtros por corporativo, fecha y empleado</a:t>
             </a:r>
-            <a:endParaRPr lang="en-US" sz="1250" dirty="0"/>
+            <a:endParaRPr lang="en-US" sz="1200" dirty="0"/>
           </a:p>
         </p:txBody>
       </p:sp>
@@ -10228,8 +10262,8 @@
         </p:nvSpPr>
         <p:spPr>
           <a:xfrm>
-            <a:off x="5852160" y="2962656"/>
-            <a:ext cx="2971800" cy="594360"/>
+            <a:off x="5852160" y="2944368"/>
+            <a:ext cx="2971800" cy="566928"/>
           </a:xfrm>
           <a:prstGeom prst="rect">
             <a:avLst/>
@@ -10245,7 +10279,7 @@
               <a:buNone/>
             </a:pPr>
             <a:r>
-              <a:rPr lang="en-US" sz="1250" dirty="0">
+              <a:rPr lang="en-US" sz="1200" dirty="0">
                 <a:solidFill>
                   <a:srgbClr val="94A3B8"/>
                 </a:solidFill>
@@ -10255,7 +10289,7 @@
               </a:rPr>
               <a:t>• Registro manual de asistencia para casos especiales</a:t>
             </a:r>
-            <a:endParaRPr lang="en-US" sz="1250" dirty="0"/>
+            <a:endParaRPr lang="en-US" sz="1200" dirty="0"/>
           </a:p>
         </p:txBody>
       </p:sp>
@@ -10267,8 +10301,8 @@
         </p:nvSpPr>
         <p:spPr>
           <a:xfrm>
-            <a:off x="5852160" y="3621024"/>
-            <a:ext cx="2971800" cy="594360"/>
+            <a:off x="5852160" y="3566160"/>
+            <a:ext cx="2971800" cy="566928"/>
           </a:xfrm>
           <a:prstGeom prst="rect">
             <a:avLst/>
@@ -10284,7 +10318,7 @@
               <a:buNone/>
             </a:pPr>
             <a:r>
-              <a:rPr lang="en-US" sz="1250" dirty="0">
+              <a:rPr lang="en-US" sz="1200" dirty="0">
                 <a:solidFill>
                   <a:srgbClr val="F8FAFC"/>
                 </a:solidFill>
@@ -10294,7 +10328,7 @@
               </a:rPr>
               <a:t>• Exportación de datos para conciliación de nómina</a:t>
             </a:r>
-            <a:endParaRPr lang="en-US" sz="1250" dirty="0"/>
+            <a:endParaRPr lang="en-US" sz="1200" dirty="0"/>
           </a:p>
         </p:txBody>
       </p:sp>
@@ -10461,23 +10495,25 @@
         <p:spPr>
           <a:xfrm>
             <a:off x="5852160" y="877824"/>
-            <a:ext cx="2971800" cy="594360"/>
-          </a:xfrm>
-          <a:prstGeom prst="rect">
-            <a:avLst/>
-          </a:prstGeom>
-          <a:noFill/>
-          <a:ln/>
-        </p:spPr>
-        <p:txBody>
-          <a:bodyPr wrap="square" rtlCol="0" anchor="t"/>
+            <a:ext cx="2971800" cy="658368"/>
+          </a:xfrm>
+          <a:prstGeom prst="rect">
+            <a:avLst/>
+          </a:prstGeom>
+          <a:noFill/>
+          <a:ln/>
+        </p:spPr>
+        <p:txBody>
+          <a:bodyPr wrap="square" rtlCol="0" anchor="t">
+            <a:spAutoFit/>
+          </a:bodyPr>
           <a:lstStyle/>
           <a:p>
             <a:pPr indent="0" marL="0">
               <a:buNone/>
             </a:pPr>
             <a:r>
-              <a:rPr lang="en-US" sz="2100" b="1" dirty="0">
+              <a:rPr lang="en-US" sz="2000" b="1" dirty="0">
                 <a:solidFill>
                   <a:srgbClr val="F8FAFC"/>
                 </a:solidFill>
@@ -10487,7 +10523,7 @@
               </a:rPr>
               <a:t>Reportes y Analítica</a:t>
             </a:r>
-            <a:endParaRPr lang="en-US" sz="2100" dirty="0"/>
+            <a:endParaRPr lang="en-US" sz="2000" dirty="0"/>
           </a:p>
         </p:txBody>
       </p:sp>
@@ -10499,7 +10535,7 @@
         </p:nvSpPr>
         <p:spPr>
           <a:xfrm>
-            <a:off x="5852160" y="1536192"/>
+            <a:off x="5852160" y="1591056"/>
             <a:ext cx="2971800" cy="0"/>
           </a:xfrm>
           <a:prstGeom prst="line">
@@ -10522,8 +10558,8 @@
         </p:nvSpPr>
         <p:spPr>
           <a:xfrm>
-            <a:off x="5852160" y="1645920"/>
-            <a:ext cx="2971800" cy="594360"/>
+            <a:off x="5852160" y="1700784"/>
+            <a:ext cx="2971800" cy="566928"/>
           </a:xfrm>
           <a:prstGeom prst="rect">
             <a:avLst/>
@@ -10539,7 +10575,7 @@
               <a:buNone/>
             </a:pPr>
             <a:r>
-              <a:rPr lang="en-US" sz="1250" dirty="0">
+              <a:rPr lang="en-US" sz="1200" dirty="0">
                 <a:solidFill>
                   <a:srgbClr val="94A3B8"/>
                 </a:solidFill>
@@ -10549,7 +10585,7 @@
               </a:rPr>
               <a:t>• 4 tipos de reporte: Asistencia, Incidencias, Tiempo trabajado, Línea de tiempo</a:t>
             </a:r>
-            <a:endParaRPr lang="en-US" sz="1250" dirty="0"/>
+            <a:endParaRPr lang="en-US" sz="1200" dirty="0"/>
           </a:p>
         </p:txBody>
       </p:sp>
@@ -10561,8 +10597,8 @@
         </p:nvSpPr>
         <p:spPr>
           <a:xfrm>
-            <a:off x="5852160" y="2304288"/>
-            <a:ext cx="2971800" cy="594360"/>
+            <a:off x="5852160" y="2322576"/>
+            <a:ext cx="2971800" cy="566928"/>
           </a:xfrm>
           <a:prstGeom prst="rect">
             <a:avLst/>
@@ -10578,7 +10614,7 @@
               <a:buNone/>
             </a:pPr>
             <a:r>
-              <a:rPr lang="en-US" sz="1250" dirty="0">
+              <a:rPr lang="en-US" sz="1200" dirty="0">
                 <a:solidFill>
                   <a:srgbClr val="F8FAFC"/>
                 </a:solidFill>
@@ -10588,7 +10624,7 @@
               </a:rPr>
               <a:t>• Filtros por rango de fechas, sucursal y empleado específico</a:t>
             </a:r>
-            <a:endParaRPr lang="en-US" sz="1250" dirty="0"/>
+            <a:endParaRPr lang="en-US" sz="1200" dirty="0"/>
           </a:p>
         </p:txBody>
       </p:sp>
@@ -10600,8 +10636,8 @@
         </p:nvSpPr>
         <p:spPr>
           <a:xfrm>
-            <a:off x="5852160" y="2962656"/>
-            <a:ext cx="2971800" cy="594360"/>
+            <a:off x="5852160" y="2944368"/>
+            <a:ext cx="2971800" cy="566928"/>
           </a:xfrm>
           <a:prstGeom prst="rect">
             <a:avLst/>
@@ -10617,7 +10653,7 @@
               <a:buNone/>
             </a:pPr>
             <a:r>
-              <a:rPr lang="en-US" sz="1250" dirty="0">
+              <a:rPr lang="en-US" sz="1200" dirty="0">
                 <a:solidFill>
                   <a:srgbClr val="94A3B8"/>
                 </a:solidFill>
@@ -10627,7 +10663,7 @@
               </a:rPr>
               <a:t>• Exportación a Excel para análisis externos</a:t>
             </a:r>
-            <a:endParaRPr lang="en-US" sz="1250" dirty="0"/>
+            <a:endParaRPr lang="en-US" sz="1200" dirty="0"/>
           </a:p>
         </p:txBody>
       </p:sp>
@@ -10639,8 +10675,8 @@
         </p:nvSpPr>
         <p:spPr>
           <a:xfrm>
-            <a:off x="5852160" y="3621024"/>
-            <a:ext cx="2971800" cy="594360"/>
+            <a:off x="5852160" y="3566160"/>
+            <a:ext cx="2971800" cy="566928"/>
           </a:xfrm>
           <a:prstGeom prst="rect">
             <a:avLst/>
@@ -10656,7 +10692,7 @@
               <a:buNone/>
             </a:pPr>
             <a:r>
-              <a:rPr lang="en-US" sz="1250" dirty="0">
+              <a:rPr lang="en-US" sz="1200" dirty="0">
                 <a:solidFill>
                   <a:srgbClr val="F8FAFC"/>
                 </a:solidFill>
@@ -10666,7 +10702,7 @@
               </a:rPr>
               <a:t>• Cálculo preciso de horas trabajadas y tiempos de descanso</a:t>
             </a:r>
-            <a:endParaRPr lang="en-US" sz="1250" dirty="0"/>
+            <a:endParaRPr lang="en-US" sz="1200" dirty="0"/>
           </a:p>
         </p:txBody>
       </p:sp>
@@ -10833,23 +10869,25 @@
         <p:spPr>
           <a:xfrm>
             <a:off x="5852160" y="877824"/>
-            <a:ext cx="2971800" cy="594360"/>
-          </a:xfrm>
-          <a:prstGeom prst="rect">
-            <a:avLst/>
-          </a:prstGeom>
-          <a:noFill/>
-          <a:ln/>
-        </p:spPr>
-        <p:txBody>
-          <a:bodyPr wrap="square" rtlCol="0" anchor="t"/>
+            <a:ext cx="2971800" cy="658368"/>
+          </a:xfrm>
+          <a:prstGeom prst="rect">
+            <a:avLst/>
+          </a:prstGeom>
+          <a:noFill/>
+          <a:ln/>
+        </p:spPr>
+        <p:txBody>
+          <a:bodyPr wrap="square" rtlCol="0" anchor="t">
+            <a:spAutoFit/>
+          </a:bodyPr>
           <a:lstStyle/>
           <a:p>
             <a:pPr indent="0" marL="0">
               <a:buNone/>
             </a:pPr>
             <a:r>
-              <a:rPr lang="en-US" sz="2100" b="1" dirty="0">
+              <a:rPr lang="en-US" sz="2000" b="1" dirty="0">
                 <a:solidFill>
                   <a:srgbClr val="F8FAFC"/>
                 </a:solidFill>
@@ -10859,7 +10897,7 @@
               </a:rPr>
               <a:t>Calendario Laboral</a:t>
             </a:r>
-            <a:endParaRPr lang="en-US" sz="2100" dirty="0"/>
+            <a:endParaRPr lang="en-US" sz="2000" dirty="0"/>
           </a:p>
         </p:txBody>
       </p:sp>
@@ -10871,7 +10909,7 @@
         </p:nvSpPr>
         <p:spPr>
           <a:xfrm>
-            <a:off x="5852160" y="1536192"/>
+            <a:off x="5852160" y="1591056"/>
             <a:ext cx="2971800" cy="0"/>
           </a:xfrm>
           <a:prstGeom prst="line">
@@ -10894,8 +10932,8 @@
         </p:nvSpPr>
         <p:spPr>
           <a:xfrm>
-            <a:off x="5852160" y="1645920"/>
-            <a:ext cx="2971800" cy="594360"/>
+            <a:off x="5852160" y="1700784"/>
+            <a:ext cx="2971800" cy="566928"/>
           </a:xfrm>
           <a:prstGeom prst="rect">
             <a:avLst/>
@@ -10911,7 +10949,7 @@
               <a:buNone/>
             </a:pPr>
             <a:r>
-              <a:rPr lang="en-US" sz="1250" dirty="0">
+              <a:rPr lang="en-US" sz="1200" dirty="0">
                 <a:solidFill>
                   <a:srgbClr val="94A3B8"/>
                 </a:solidFill>
@@ -10921,7 +10959,7 @@
               </a:rPr>
               <a:t>• Vista mensual de asistencias y ausencias por empleado</a:t>
             </a:r>
-            <a:endParaRPr lang="en-US" sz="1250" dirty="0"/>
+            <a:endParaRPr lang="en-US" sz="1200" dirty="0"/>
           </a:p>
         </p:txBody>
       </p:sp>
@@ -10933,8 +10971,8 @@
         </p:nvSpPr>
         <p:spPr>
           <a:xfrm>
-            <a:off x="5852160" y="2304288"/>
-            <a:ext cx="2971800" cy="594360"/>
+            <a:off x="5852160" y="2322576"/>
+            <a:ext cx="2971800" cy="566928"/>
           </a:xfrm>
           <a:prstGeom prst="rect">
             <a:avLst/>
@@ -10950,7 +10988,7 @@
               <a:buNone/>
             </a:pPr>
             <a:r>
-              <a:rPr lang="en-US" sz="1250" dirty="0">
+              <a:rPr lang="en-US" sz="1200" dirty="0">
                 <a:solidFill>
                   <a:srgbClr val="F8FAFC"/>
                 </a:solidFill>
@@ -10960,7 +10998,7 @@
               </a:rPr>
               <a:t>• Indicadores visuales por tipo de registro y estado</a:t>
             </a:r>
-            <a:endParaRPr lang="en-US" sz="1250" dirty="0"/>
+            <a:endParaRPr lang="en-US" sz="1200" dirty="0"/>
           </a:p>
         </p:txBody>
       </p:sp>
@@ -10972,8 +11010,8 @@
         </p:nvSpPr>
         <p:spPr>
           <a:xfrm>
-            <a:off x="5852160" y="2962656"/>
-            <a:ext cx="2971800" cy="594360"/>
+            <a:off x="5852160" y="2944368"/>
+            <a:ext cx="2971800" cy="566928"/>
           </a:xfrm>
           <a:prstGeom prst="rect">
             <a:avLst/>
@@ -10989,7 +11027,7 @@
               <a:buNone/>
             </a:pPr>
             <a:r>
-              <a:rPr lang="en-US" sz="1250" dirty="0">
+              <a:rPr lang="en-US" sz="1200" dirty="0">
                 <a:solidFill>
                   <a:srgbClr val="94A3B8"/>
                 </a:solidFill>
@@ -10999,7 +11037,7 @@
               </a:rPr>
               <a:t>• Integración con horarios asignados y días festivos</a:t>
             </a:r>
-            <a:endParaRPr lang="en-US" sz="1250" dirty="0"/>
+            <a:endParaRPr lang="en-US" sz="1200" dirty="0"/>
           </a:p>
         </p:txBody>
       </p:sp>
@@ -11011,8 +11049,8 @@
         </p:nvSpPr>
         <p:spPr>
           <a:xfrm>
-            <a:off x="5852160" y="3621024"/>
-            <a:ext cx="2971800" cy="594360"/>
+            <a:off x="5852160" y="3566160"/>
+            <a:ext cx="2971800" cy="566928"/>
           </a:xfrm>
           <a:prstGeom prst="rect">
             <a:avLst/>
@@ -11028,7 +11066,7 @@
               <a:buNone/>
             </a:pPr>
             <a:r>
-              <a:rPr lang="en-US" sz="1250" dirty="0">
+              <a:rPr lang="en-US" sz="1200" dirty="0">
                 <a:solidFill>
                   <a:srgbClr val="F8FAFC"/>
                 </a:solidFill>
@@ -11038,7 +11076,7 @@
               </a:rPr>
               <a:t>• Identificación rápida de patrones de ausentismo</a:t>
             </a:r>
-            <a:endParaRPr lang="en-US" sz="1250" dirty="0"/>
+            <a:endParaRPr lang="en-US" sz="1200" dirty="0"/>
           </a:p>
         </p:txBody>
       </p:sp>
@@ -11205,23 +11243,25 @@
         <p:spPr>
           <a:xfrm>
             <a:off x="5852160" y="877824"/>
-            <a:ext cx="2971800" cy="594360"/>
-          </a:xfrm>
-          <a:prstGeom prst="rect">
-            <a:avLst/>
-          </a:prstGeom>
-          <a:noFill/>
-          <a:ln/>
-        </p:spPr>
-        <p:txBody>
-          <a:bodyPr wrap="square" rtlCol="0" anchor="t"/>
+            <a:ext cx="2971800" cy="658368"/>
+          </a:xfrm>
+          <a:prstGeom prst="rect">
+            <a:avLst/>
+          </a:prstGeom>
+          <a:noFill/>
+          <a:ln/>
+        </p:spPr>
+        <p:txBody>
+          <a:bodyPr wrap="square" rtlCol="0" anchor="t">
+            <a:spAutoFit/>
+          </a:bodyPr>
           <a:lstStyle/>
           <a:p>
             <a:pPr indent="0" marL="0">
               <a:buNone/>
             </a:pPr>
             <a:r>
-              <a:rPr lang="en-US" sz="2100" b="1" dirty="0">
+              <a:rPr lang="en-US" sz="2000" b="1" dirty="0">
                 <a:solidFill>
                   <a:srgbClr val="F8FAFC"/>
                 </a:solidFill>
@@ -11231,7 +11271,7 @@
               </a:rPr>
               <a:t>Mapa de Sucursales</a:t>
             </a:r>
-            <a:endParaRPr lang="en-US" sz="2100" dirty="0"/>
+            <a:endParaRPr lang="en-US" sz="2000" dirty="0"/>
           </a:p>
         </p:txBody>
       </p:sp>
@@ -11243,7 +11283,7 @@
         </p:nvSpPr>
         <p:spPr>
           <a:xfrm>
-            <a:off x="5852160" y="1536192"/>
+            <a:off x="5852160" y="1591056"/>
             <a:ext cx="2971800" cy="0"/>
           </a:xfrm>
           <a:prstGeom prst="line">
@@ -11266,8 +11306,8 @@
         </p:nvSpPr>
         <p:spPr>
           <a:xfrm>
-            <a:off x="5852160" y="1645920"/>
-            <a:ext cx="2971800" cy="594360"/>
+            <a:off x="5852160" y="1700784"/>
+            <a:ext cx="2971800" cy="566928"/>
           </a:xfrm>
           <a:prstGeom prst="rect">
             <a:avLst/>
@@ -11283,7 +11323,7 @@
               <a:buNone/>
             </a:pPr>
             <a:r>
-              <a:rPr lang="en-US" sz="1250" dirty="0">
+              <a:rPr lang="en-US" sz="1200" dirty="0">
                 <a:solidFill>
                   <a:srgbClr val="94A3B8"/>
                 </a:solidFill>
@@ -11293,7 +11333,7 @@
               </a:rPr>
               <a:t>• Visualización geográfica de todas las sucursales activas</a:t>
             </a:r>
-            <a:endParaRPr lang="en-US" sz="1250" dirty="0"/>
+            <a:endParaRPr lang="en-US" sz="1200" dirty="0"/>
           </a:p>
         </p:txBody>
       </p:sp>
@@ -11305,8 +11345,8 @@
         </p:nvSpPr>
         <p:spPr>
           <a:xfrm>
-            <a:off x="5852160" y="2304288"/>
-            <a:ext cx="2971800" cy="594360"/>
+            <a:off x="5852160" y="2322576"/>
+            <a:ext cx="2971800" cy="566928"/>
           </a:xfrm>
           <a:prstGeom prst="rect">
             <a:avLst/>
@@ -11322,7 +11362,7 @@
               <a:buNone/>
             </a:pPr>
             <a:r>
-              <a:rPr lang="en-US" sz="1250" dirty="0">
+              <a:rPr lang="en-US" sz="1200" dirty="0">
                 <a:solidFill>
                   <a:srgbClr val="F8FAFC"/>
                 </a:solidFill>
@@ -11332,7 +11372,7 @@
               </a:rPr>
               <a:t>• Información de contacto y datos operativos por ubicación</a:t>
             </a:r>
-            <a:endParaRPr lang="en-US" sz="1250" dirty="0"/>
+            <a:endParaRPr lang="en-US" sz="1200" dirty="0"/>
           </a:p>
         </p:txBody>
       </p:sp>
@@ -11344,8 +11384,8 @@
         </p:nvSpPr>
         <p:spPr>
           <a:xfrm>
-            <a:off x="5852160" y="2962656"/>
-            <a:ext cx="2971800" cy="594360"/>
+            <a:off x="5852160" y="2944368"/>
+            <a:ext cx="2971800" cy="566928"/>
           </a:xfrm>
           <a:prstGeom prst="rect">
             <a:avLst/>
@@ -11361,7 +11401,7 @@
               <a:buNone/>
             </a:pPr>
             <a:r>
-              <a:rPr lang="en-US" sz="1250" dirty="0">
+              <a:rPr lang="en-US" sz="1200" dirty="0">
                 <a:solidFill>
                   <a:srgbClr val="94A3B8"/>
                 </a:solidFill>
@@ -11371,7 +11411,7 @@
               </a:rPr>
               <a:t>• Integración con GPS para verificación de ubicación en registro</a:t>
             </a:r>
-            <a:endParaRPr lang="en-US" sz="1250" dirty="0"/>
+            <a:endParaRPr lang="en-US" sz="1200" dirty="0"/>
           </a:p>
         </p:txBody>
       </p:sp>
@@ -11383,8 +11423,8 @@
         </p:nvSpPr>
         <p:spPr>
           <a:xfrm>
-            <a:off x="5852160" y="3621024"/>
-            <a:ext cx="2971800" cy="594360"/>
+            <a:off x="5852160" y="3566160"/>
+            <a:ext cx="2971800" cy="566928"/>
           </a:xfrm>
           <a:prstGeom prst="rect">
             <a:avLst/>
@@ -11400,7 +11440,7 @@
               <a:buNone/>
             </a:pPr>
             <a:r>
-              <a:rPr lang="en-US" sz="1250" dirty="0">
+              <a:rPr lang="en-US" sz="1200" dirty="0">
                 <a:solidFill>
                   <a:srgbClr val="F8FAFC"/>
                 </a:solidFill>
@@ -11410,7 +11450,7 @@
               </a:rPr>
               <a:t>• Vista consolidada de la red de sucursales de la organización</a:t>
             </a:r>
-            <a:endParaRPr lang="en-US" sz="1250" dirty="0"/>
+            <a:endParaRPr lang="en-US" sz="1200" dirty="0"/>
           </a:p>
         </p:txBody>
       </p:sp>
@@ -11577,23 +11617,25 @@
         <p:spPr>
           <a:xfrm>
             <a:off x="5852160" y="877824"/>
-            <a:ext cx="2971800" cy="594360"/>
-          </a:xfrm>
-          <a:prstGeom prst="rect">
-            <a:avLst/>
-          </a:prstGeom>
-          <a:noFill/>
-          <a:ln/>
-        </p:spPr>
-        <p:txBody>
-          <a:bodyPr wrap="square" rtlCol="0" anchor="t"/>
+            <a:ext cx="2971800" cy="658368"/>
+          </a:xfrm>
+          <a:prstGeom prst="rect">
+            <a:avLst/>
+          </a:prstGeom>
+          <a:noFill/>
+          <a:ln/>
+        </p:spPr>
+        <p:txBody>
+          <a:bodyPr wrap="square" rtlCol="0" anchor="t">
+            <a:spAutoFit/>
+          </a:bodyPr>
           <a:lstStyle/>
           <a:p>
             <a:pPr indent="0" marL="0">
               <a:buNone/>
             </a:pPr>
             <a:r>
-              <a:rPr lang="en-US" sz="2100" b="1" dirty="0">
+              <a:rPr lang="en-US" sz="2000" b="1" dirty="0">
                 <a:solidFill>
                   <a:srgbClr val="F8FAFC"/>
                 </a:solidFill>
@@ -11601,9 +11643,9 @@
                 <a:ea typeface="Calibri" pitchFamily="34" charset="-122"/>
                 <a:cs typeface="Calibri" pitchFamily="34" charset="-120"/>
               </a:rPr>
-              <a:t>Organigrama Organizacional</a:t>
-            </a:r>
-            <a:endParaRPr lang="en-US" sz="2100" dirty="0"/>
+              <a:t>Organigrama</a:t>
+            </a:r>
+            <a:endParaRPr lang="en-US" sz="2000" dirty="0"/>
           </a:p>
         </p:txBody>
       </p:sp>
@@ -11615,7 +11657,7 @@
         </p:nvSpPr>
         <p:spPr>
           <a:xfrm>
-            <a:off x="5852160" y="1536192"/>
+            <a:off x="5852160" y="1591056"/>
             <a:ext cx="2971800" cy="0"/>
           </a:xfrm>
           <a:prstGeom prst="line">
@@ -11638,8 +11680,8 @@
         </p:nvSpPr>
         <p:spPr>
           <a:xfrm>
-            <a:off x="5852160" y="1645920"/>
-            <a:ext cx="2971800" cy="594360"/>
+            <a:off x="5852160" y="1700784"/>
+            <a:ext cx="2971800" cy="566928"/>
           </a:xfrm>
           <a:prstGeom prst="rect">
             <a:avLst/>
@@ -11655,7 +11697,7 @@
               <a:buNone/>
             </a:pPr>
             <a:r>
-              <a:rPr lang="en-US" sz="1250" dirty="0">
+              <a:rPr lang="en-US" sz="1200" dirty="0">
                 <a:solidFill>
                   <a:srgbClr val="94A3B8"/>
                 </a:solidFill>
@@ -11665,7 +11707,7 @@
               </a:rPr>
               <a:t>• Estructura jerárquica visual de la organización</a:t>
             </a:r>
-            <a:endParaRPr lang="en-US" sz="1250" dirty="0"/>
+            <a:endParaRPr lang="en-US" sz="1200" dirty="0"/>
           </a:p>
         </p:txBody>
       </p:sp>
@@ -11677,8 +11719,8 @@
         </p:nvSpPr>
         <p:spPr>
           <a:xfrm>
-            <a:off x="5852160" y="2304288"/>
-            <a:ext cx="2971800" cy="594360"/>
+            <a:off x="5852160" y="2322576"/>
+            <a:ext cx="2971800" cy="566928"/>
           </a:xfrm>
           <a:prstGeom prst="rect">
             <a:avLst/>
@@ -11694,7 +11736,7 @@
               <a:buNone/>
             </a:pPr>
             <a:r>
-              <a:rPr lang="en-US" sz="1250" dirty="0">
+              <a:rPr lang="en-US" sz="1200" dirty="0">
                 <a:solidFill>
                   <a:srgbClr val="F8FAFC"/>
                 </a:solidFill>
@@ -11704,7 +11746,7 @@
               </a:rPr>
               <a:t>• Relación entre jefes inmediatos y colaboradores</a:t>
             </a:r>
-            <a:endParaRPr lang="en-US" sz="1250" dirty="0"/>
+            <a:endParaRPr lang="en-US" sz="1200" dirty="0"/>
           </a:p>
         </p:txBody>
       </p:sp>
@@ -11716,8 +11758,8 @@
         </p:nvSpPr>
         <p:spPr>
           <a:xfrm>
-            <a:off x="5852160" y="2962656"/>
-            <a:ext cx="2971800" cy="594360"/>
+            <a:off x="5852160" y="2944368"/>
+            <a:ext cx="2971800" cy="566928"/>
           </a:xfrm>
           <a:prstGeom prst="rect">
             <a:avLst/>
@@ -11733,7 +11775,7 @@
               <a:buNone/>
             </a:pPr>
             <a:r>
-              <a:rPr lang="en-US" sz="1250" dirty="0">
+              <a:rPr lang="en-US" sz="1200" dirty="0">
                 <a:solidFill>
                   <a:srgbClr val="94A3B8"/>
                 </a:solidFill>
@@ -11743,7 +11785,7 @@
               </a:rPr>
               <a:t>• Navegación interactiva por niveles y departamentos</a:t>
             </a:r>
-            <a:endParaRPr lang="en-US" sz="1250" dirty="0"/>
+            <a:endParaRPr lang="en-US" sz="1200" dirty="0"/>
           </a:p>
         </p:txBody>
       </p:sp>
@@ -11755,8 +11797,8 @@
         </p:nvSpPr>
         <p:spPr>
           <a:xfrm>
-            <a:off x="5852160" y="3621024"/>
-            <a:ext cx="2971800" cy="594360"/>
+            <a:off x="5852160" y="3566160"/>
+            <a:ext cx="2971800" cy="566928"/>
           </a:xfrm>
           <a:prstGeom prst="rect">
             <a:avLst/>
@@ -11772,7 +11814,7 @@
               <a:buNone/>
             </a:pPr>
             <a:r>
-              <a:rPr lang="en-US" sz="1250" dirty="0">
+              <a:rPr lang="en-US" sz="1200" dirty="0">
                 <a:solidFill>
                   <a:srgbClr val="F8FAFC"/>
                 </a:solidFill>
@@ -11782,7 +11824,7 @@
               </a:rPr>
               <a:t>• Exportable para reportes de recursos humanos</a:t>
             </a:r>
-            <a:endParaRPr lang="en-US" sz="1250" dirty="0"/>
+            <a:endParaRPr lang="en-US" sz="1200" dirty="0"/>
           </a:p>
         </p:txBody>
       </p:sp>
@@ -11949,23 +11991,25 @@
         <p:spPr>
           <a:xfrm>
             <a:off x="5852160" y="877824"/>
-            <a:ext cx="2971800" cy="594360"/>
-          </a:xfrm>
-          <a:prstGeom prst="rect">
-            <a:avLst/>
-          </a:prstGeom>
-          <a:noFill/>
-          <a:ln/>
-        </p:spPr>
-        <p:txBody>
-          <a:bodyPr wrap="square" rtlCol="0" anchor="t"/>
+            <a:ext cx="2971800" cy="658368"/>
+          </a:xfrm>
+          <a:prstGeom prst="rect">
+            <a:avLst/>
+          </a:prstGeom>
+          <a:noFill/>
+          <a:ln/>
+        </p:spPr>
+        <p:txBody>
+          <a:bodyPr wrap="square" rtlCol="0" anchor="t">
+            <a:spAutoFit/>
+          </a:bodyPr>
           <a:lstStyle/>
           <a:p>
             <a:pPr indent="0" marL="0">
               <a:buNone/>
             </a:pPr>
             <a:r>
-              <a:rPr lang="en-US" sz="2100" b="1" dirty="0">
+              <a:rPr lang="en-US" sz="2000" b="1" dirty="0">
                 <a:solidFill>
                   <a:srgbClr val="F8FAFC"/>
                 </a:solidFill>
@@ -11975,7 +12019,7 @@
               </a:rPr>
               <a:t>Gestión de Empleados</a:t>
             </a:r>
-            <a:endParaRPr lang="en-US" sz="2100" dirty="0"/>
+            <a:endParaRPr lang="en-US" sz="2000" dirty="0"/>
           </a:p>
         </p:txBody>
       </p:sp>
@@ -11987,7 +12031,7 @@
         </p:nvSpPr>
         <p:spPr>
           <a:xfrm>
-            <a:off x="5852160" y="1536192"/>
+            <a:off x="5852160" y="1591056"/>
             <a:ext cx="2971800" cy="0"/>
           </a:xfrm>
           <a:prstGeom prst="line">
@@ -12010,8 +12054,8 @@
         </p:nvSpPr>
         <p:spPr>
           <a:xfrm>
-            <a:off x="5852160" y="1645920"/>
-            <a:ext cx="2971800" cy="594360"/>
+            <a:off x="5852160" y="1700784"/>
+            <a:ext cx="2971800" cy="566928"/>
           </a:xfrm>
           <a:prstGeom prst="rect">
             <a:avLst/>
@@ -12027,7 +12071,7 @@
               <a:buNone/>
             </a:pPr>
             <a:r>
-              <a:rPr lang="en-US" sz="1250" dirty="0">
+              <a:rPr lang="en-US" sz="1200" dirty="0">
                 <a:solidFill>
                   <a:srgbClr val="94A3B8"/>
                 </a:solidFill>
@@ -12037,7 +12081,7 @@
               </a:rPr>
               <a:t>• Alta, baja y modificación de empleados con control de roles</a:t>
             </a:r>
-            <a:endParaRPr lang="en-US" sz="1250" dirty="0"/>
+            <a:endParaRPr lang="en-US" sz="1200" dirty="0"/>
           </a:p>
         </p:txBody>
       </p:sp>
@@ -12049,8 +12093,8 @@
         </p:nvSpPr>
         <p:spPr>
           <a:xfrm>
-            <a:off x="5852160" y="2304288"/>
-            <a:ext cx="2971800" cy="594360"/>
+            <a:off x="5852160" y="2322576"/>
+            <a:ext cx="2971800" cy="566928"/>
           </a:xfrm>
           <a:prstGeom prst="rect">
             <a:avLst/>
@@ -12066,7 +12110,7 @@
               <a:buNone/>
             </a:pPr>
             <a:r>
-              <a:rPr lang="en-US" sz="1250" dirty="0">
+              <a:rPr lang="en-US" sz="1200" dirty="0">
                 <a:solidFill>
                   <a:srgbClr val="F8FAFC"/>
                 </a:solidFill>
@@ -12076,7 +12120,7 @@
               </a:rPr>
               <a:t>• Asignación de sucursal, grupo, horario y jefe inmediato</a:t>
             </a:r>
-            <a:endParaRPr lang="en-US" sz="1250" dirty="0"/>
+            <a:endParaRPr lang="en-US" sz="1200" dirty="0"/>
           </a:p>
         </p:txBody>
       </p:sp>
@@ -12088,8 +12132,8 @@
         </p:nvSpPr>
         <p:spPr>
           <a:xfrm>
-            <a:off x="5852160" y="2962656"/>
-            <a:ext cx="2971800" cy="594360"/>
+            <a:off x="5852160" y="2944368"/>
+            <a:ext cx="2971800" cy="566928"/>
           </a:xfrm>
           <a:prstGeom prst="rect">
             <a:avLst/>
@@ -12105,7 +12149,7 @@
               <a:buNone/>
             </a:pPr>
             <a:r>
-              <a:rPr lang="en-US" sz="1250" dirty="0">
+              <a:rPr lang="en-US" sz="1200" dirty="0">
                 <a:solidFill>
                   <a:srgbClr val="94A3B8"/>
                 </a:solidFill>
@@ -12115,7 +12159,7 @@
               </a:rPr>
               <a:t>• Validación en tiempo real de correo único por colaborador</a:t>
             </a:r>
-            <a:endParaRPr lang="en-US" sz="1250" dirty="0"/>
+            <a:endParaRPr lang="en-US" sz="1200" dirty="0"/>
           </a:p>
         </p:txBody>
       </p:sp>
@@ -12127,8 +12171,8 @@
         </p:nvSpPr>
         <p:spPr>
           <a:xfrm>
-            <a:off x="5852160" y="3621024"/>
-            <a:ext cx="2971800" cy="594360"/>
+            <a:off x="5852160" y="3566160"/>
+            <a:ext cx="2971800" cy="566928"/>
           </a:xfrm>
           <a:prstGeom prst="rect">
             <a:avLst/>
@@ -12144,7 +12188,7 @@
               <a:buNone/>
             </a:pPr>
             <a:r>
-              <a:rPr lang="en-US" sz="1250" dirty="0">
+              <a:rPr lang="en-US" sz="1200" dirty="0">
                 <a:solidFill>
                   <a:srgbClr val="F8FAFC"/>
                 </a:solidFill>
@@ -12154,7 +12198,7 @@
               </a:rPr>
               <a:t>• Paginación y búsqueda avanzada para grandes volúmenes</a:t>
             </a:r>
-            <a:endParaRPr lang="en-US" sz="1250" dirty="0"/>
+            <a:endParaRPr lang="en-US" sz="1200" dirty="0"/>
           </a:p>
         </p:txBody>
       </p:sp>

</xml_diff>